<commit_message>
Changing Ccluster for Basline
Due t the reorder of HDI, for baseline
3->2
4->3
2->4
10->9
9->10
</commit_message>
<xml_diff>
--- a/Figures/WellBeingAnalysis/Radarcharts_combined.pptx
+++ b/Figures/WellBeingAnalysis/Radarcharts_combined.pptx
@@ -376,7 +376,7 @@
           <a:p>
             <a:fld id="{771F9CFD-3BC0-4963-B012-81B178BD77EE}" type="datetimeFigureOut">
               <a:rPr lang="en-US" smtClean="0"/>
-              <a:t>10/16/2025</a:t>
+              <a:t>11/18/2025</a:t>
             </a:fld>
             <a:endParaRPr lang="en-US"/>
           </a:p>
@@ -546,7 +546,7 @@
           <a:p>
             <a:fld id="{771F9CFD-3BC0-4963-B012-81B178BD77EE}" type="datetimeFigureOut">
               <a:rPr lang="en-US" smtClean="0"/>
-              <a:t>10/16/2025</a:t>
+              <a:t>11/18/2025</a:t>
             </a:fld>
             <a:endParaRPr lang="en-US"/>
           </a:p>
@@ -726,7 +726,7 @@
           <a:p>
             <a:fld id="{771F9CFD-3BC0-4963-B012-81B178BD77EE}" type="datetimeFigureOut">
               <a:rPr lang="en-US" smtClean="0"/>
-              <a:t>10/16/2025</a:t>
+              <a:t>11/18/2025</a:t>
             </a:fld>
             <a:endParaRPr lang="en-US"/>
           </a:p>
@@ -896,7 +896,7 @@
           <a:p>
             <a:fld id="{771F9CFD-3BC0-4963-B012-81B178BD77EE}" type="datetimeFigureOut">
               <a:rPr lang="en-US" smtClean="0"/>
-              <a:t>10/16/2025</a:t>
+              <a:t>11/18/2025</a:t>
             </a:fld>
             <a:endParaRPr lang="en-US"/>
           </a:p>
@@ -1142,7 +1142,7 @@
           <a:p>
             <a:fld id="{771F9CFD-3BC0-4963-B012-81B178BD77EE}" type="datetimeFigureOut">
               <a:rPr lang="en-US" smtClean="0"/>
-              <a:t>10/16/2025</a:t>
+              <a:t>11/18/2025</a:t>
             </a:fld>
             <a:endParaRPr lang="en-US"/>
           </a:p>
@@ -1374,7 +1374,7 @@
           <a:p>
             <a:fld id="{771F9CFD-3BC0-4963-B012-81B178BD77EE}" type="datetimeFigureOut">
               <a:rPr lang="en-US" smtClean="0"/>
-              <a:t>10/16/2025</a:t>
+              <a:t>11/18/2025</a:t>
             </a:fld>
             <a:endParaRPr lang="en-US"/>
           </a:p>
@@ -1741,7 +1741,7 @@
           <a:p>
             <a:fld id="{771F9CFD-3BC0-4963-B012-81B178BD77EE}" type="datetimeFigureOut">
               <a:rPr lang="en-US" smtClean="0"/>
-              <a:t>10/16/2025</a:t>
+              <a:t>11/18/2025</a:t>
             </a:fld>
             <a:endParaRPr lang="en-US"/>
           </a:p>
@@ -1859,7 +1859,7 @@
           <a:p>
             <a:fld id="{771F9CFD-3BC0-4963-B012-81B178BD77EE}" type="datetimeFigureOut">
               <a:rPr lang="en-US" smtClean="0"/>
-              <a:t>10/16/2025</a:t>
+              <a:t>11/18/2025</a:t>
             </a:fld>
             <a:endParaRPr lang="en-US"/>
           </a:p>
@@ -1954,7 +1954,7 @@
           <a:p>
             <a:fld id="{771F9CFD-3BC0-4963-B012-81B178BD77EE}" type="datetimeFigureOut">
               <a:rPr lang="en-US" smtClean="0"/>
-              <a:t>10/16/2025</a:t>
+              <a:t>11/18/2025</a:t>
             </a:fld>
             <a:endParaRPr lang="en-US"/>
           </a:p>
@@ -2231,7 +2231,7 @@
           <a:p>
             <a:fld id="{771F9CFD-3BC0-4963-B012-81B178BD77EE}" type="datetimeFigureOut">
               <a:rPr lang="en-US" smtClean="0"/>
-              <a:t>10/16/2025</a:t>
+              <a:t>11/18/2025</a:t>
             </a:fld>
             <a:endParaRPr lang="en-US"/>
           </a:p>
@@ -2488,7 +2488,7 @@
           <a:p>
             <a:fld id="{771F9CFD-3BC0-4963-B012-81B178BD77EE}" type="datetimeFigureOut">
               <a:rPr lang="en-US" smtClean="0"/>
-              <a:t>10/16/2025</a:t>
+              <a:t>11/18/2025</a:t>
             </a:fld>
             <a:endParaRPr lang="en-US"/>
           </a:p>
@@ -2701,7 +2701,7 @@
           <a:p>
             <a:fld id="{771F9CFD-3BC0-4963-B012-81B178BD77EE}" type="datetimeFigureOut">
               <a:rPr lang="en-US" smtClean="0"/>
-              <a:t>10/16/2025</a:t>
+              <a:t>11/18/2025</a:t>
             </a:fld>
             <a:endParaRPr lang="en-US"/>
           </a:p>
@@ -3106,117 +3106,12 @@
           <a:chExt cx="0" cy="0"/>
         </a:xfrm>
       </p:grpSpPr>
-      <p:pic>
-        <p:nvPicPr>
-          <p:cNvPr id="27" name="Picture 26">
+      <p:grpSp>
+        <p:nvGrpSpPr>
+          <p:cNvPr id="8" name="Group 7">
             <a:extLst>
               <a:ext uri="{FF2B5EF4-FFF2-40B4-BE49-F238E27FC236}">
-                <a16:creationId xmlns:a16="http://schemas.microsoft.com/office/drawing/2014/main" id="{607EF7E0-F227-3C1A-31E3-F1A33622B09D}"/>
-              </a:ext>
-            </a:extLst>
-          </p:cNvPr>
-          <p:cNvPicPr>
-            <a:picLocks noChangeAspect="1"/>
-          </p:cNvPicPr>
-          <p:nvPr/>
-        </p:nvPicPr>
-        <p:blipFill>
-          <a:blip r:embed="rId2">
-            <a:extLst>
-              <a:ext uri="{28A0092B-C50C-407E-A947-70E740481C1C}">
-                <a14:useLocalDpi xmlns:a14="http://schemas.microsoft.com/office/drawing/2010/main" val="0"/>
-              </a:ext>
-            </a:extLst>
-          </a:blip>
-          <a:srcRect/>
-          <a:stretch/>
-        </p:blipFill>
-        <p:spPr>
-          <a:xfrm>
-            <a:off x="1753837" y="2430764"/>
-            <a:ext cx="2833500" cy="2833500"/>
-          </a:xfrm>
-          <a:prstGeom prst="rect">
-            <a:avLst/>
-          </a:prstGeom>
-        </p:spPr>
-      </p:pic>
-      <p:pic>
-        <p:nvPicPr>
-          <p:cNvPr id="29" name="Picture 28">
-            <a:extLst>
-              <a:ext uri="{FF2B5EF4-FFF2-40B4-BE49-F238E27FC236}">
-                <a16:creationId xmlns:a16="http://schemas.microsoft.com/office/drawing/2014/main" id="{147EE75E-6492-4001-1FC3-BEC8A26BAC3C}"/>
-              </a:ext>
-            </a:extLst>
-          </p:cNvPr>
-          <p:cNvPicPr>
-            <a:picLocks noChangeAspect="1"/>
-          </p:cNvPicPr>
-          <p:nvPr/>
-        </p:nvPicPr>
-        <p:blipFill>
-          <a:blip r:embed="rId3">
-            <a:extLst>
-              <a:ext uri="{28A0092B-C50C-407E-A947-70E740481C1C}">
-                <a14:useLocalDpi xmlns:a14="http://schemas.microsoft.com/office/drawing/2010/main" val="0"/>
-              </a:ext>
-            </a:extLst>
-          </a:blip>
-          <a:srcRect/>
-          <a:stretch/>
-        </p:blipFill>
-        <p:spPr>
-          <a:xfrm>
-            <a:off x="4330163" y="2430764"/>
-            <a:ext cx="2833500" cy="2833500"/>
-          </a:xfrm>
-          <a:prstGeom prst="rect">
-            <a:avLst/>
-          </a:prstGeom>
-        </p:spPr>
-      </p:pic>
-      <p:pic>
-        <p:nvPicPr>
-          <p:cNvPr id="31" name="Picture 30">
-            <a:extLst>
-              <a:ext uri="{FF2B5EF4-FFF2-40B4-BE49-F238E27FC236}">
-                <a16:creationId xmlns:a16="http://schemas.microsoft.com/office/drawing/2014/main" id="{DF16A4FA-7A2D-CCA8-3C55-3ADAD76D49CF}"/>
-              </a:ext>
-            </a:extLst>
-          </p:cNvPr>
-          <p:cNvPicPr>
-            <a:picLocks noChangeAspect="1"/>
-          </p:cNvPicPr>
-          <p:nvPr/>
-        </p:nvPicPr>
-        <p:blipFill>
-          <a:blip r:embed="rId4">
-            <a:extLst>
-              <a:ext uri="{28A0092B-C50C-407E-A947-70E740481C1C}">
-                <a14:useLocalDpi xmlns:a14="http://schemas.microsoft.com/office/drawing/2010/main" val="0"/>
-              </a:ext>
-            </a:extLst>
-          </a:blip>
-          <a:srcRect/>
-          <a:stretch/>
-        </p:blipFill>
-        <p:spPr>
-          <a:xfrm>
-            <a:off x="6852490" y="2430764"/>
-            <a:ext cx="2833500" cy="2833500"/>
-          </a:xfrm>
-          <a:prstGeom prst="rect">
-            <a:avLst/>
-          </a:prstGeom>
-        </p:spPr>
-      </p:pic>
-      <p:grpSp>
-        <p:nvGrpSpPr>
-          <p:cNvPr id="51" name="Group 50">
-            <a:extLst>
-              <a:ext uri="{FF2B5EF4-FFF2-40B4-BE49-F238E27FC236}">
-                <a16:creationId xmlns:a16="http://schemas.microsoft.com/office/drawing/2014/main" id="{85056089-343E-1D31-CACD-1271730819FC}"/>
+                <a16:creationId xmlns:a16="http://schemas.microsoft.com/office/drawing/2014/main" id="{E53E6596-652E-6CDC-1CD5-2EF39F877CF9}"/>
               </a:ext>
             </a:extLst>
           </p:cNvPr>
@@ -3225,18 +3120,18 @@
         </p:nvGrpSpPr>
         <p:grpSpPr>
           <a:xfrm>
-            <a:off x="512923" y="4836286"/>
-            <a:ext cx="10434231" cy="5425562"/>
-            <a:chOff x="512923" y="4836286"/>
-            <a:chExt cx="10434231" cy="5425562"/>
+            <a:off x="512923" y="2430764"/>
+            <a:ext cx="10434231" cy="7831084"/>
+            <a:chOff x="512923" y="2430764"/>
+            <a:chExt cx="10434231" cy="7831084"/>
           </a:xfrm>
         </p:grpSpPr>
         <p:pic>
           <p:nvPicPr>
-            <p:cNvPr id="39" name="Picture 38">
+            <p:cNvPr id="5" name="Picture 4" descr="A graph of a graph&#10;&#10;AI-generated content may be incorrect.">
               <a:extLst>
                 <a:ext uri="{FF2B5EF4-FFF2-40B4-BE49-F238E27FC236}">
-                  <a16:creationId xmlns:a16="http://schemas.microsoft.com/office/drawing/2014/main" id="{A50F4D04-F764-4FF9-9B25-1F4A575F753F}"/>
+                  <a16:creationId xmlns:a16="http://schemas.microsoft.com/office/drawing/2014/main" id="{35D0D4F8-92D1-228E-FD08-A1AEC891FF48}"/>
                 </a:ext>
               </a:extLst>
             </p:cNvPr>
@@ -3246,7 +3141,81 @@
             <p:nvPr/>
           </p:nvPicPr>
           <p:blipFill>
-            <a:blip r:embed="rId5">
+            <a:blip r:embed="rId2">
+              <a:alphaModFix/>
+              <a:extLst>
+                <a:ext uri="{28A0092B-C50C-407E-A947-70E740481C1C}">
+                  <a14:useLocalDpi xmlns:a14="http://schemas.microsoft.com/office/drawing/2010/main" val="0"/>
+                </a:ext>
+              </a:extLst>
+            </a:blip>
+            <a:stretch>
+              <a:fillRect/>
+            </a:stretch>
+          </p:blipFill>
+          <p:spPr>
+            <a:xfrm>
+              <a:off x="6857171" y="2434706"/>
+              <a:ext cx="2834640" cy="2834640"/>
+            </a:xfrm>
+            <a:prstGeom prst="rect">
+              <a:avLst/>
+            </a:prstGeom>
+          </p:spPr>
+        </p:pic>
+        <p:pic>
+          <p:nvPicPr>
+            <p:cNvPr id="3" name="Picture 2" descr="A graph of a graph&#10;&#10;AI-generated content may be incorrect.">
+              <a:extLst>
+                <a:ext uri="{FF2B5EF4-FFF2-40B4-BE49-F238E27FC236}">
+                  <a16:creationId xmlns:a16="http://schemas.microsoft.com/office/drawing/2014/main" id="{5A136D3A-388B-5016-BA83-3F11E5B2C8B3}"/>
+                </a:ext>
+              </a:extLst>
+            </p:cNvPr>
+            <p:cNvPicPr>
+              <a:picLocks noChangeAspect="1"/>
+            </p:cNvPicPr>
+            <p:nvPr/>
+          </p:nvPicPr>
+          <p:blipFill>
+            <a:blip r:embed="rId3">
+              <a:alphaModFix/>
+              <a:extLst>
+                <a:ext uri="{28A0092B-C50C-407E-A947-70E740481C1C}">
+                  <a14:useLocalDpi xmlns:a14="http://schemas.microsoft.com/office/drawing/2010/main" val="0"/>
+                </a:ext>
+              </a:extLst>
+            </a:blip>
+            <a:stretch>
+              <a:fillRect/>
+            </a:stretch>
+          </p:blipFill>
+          <p:spPr>
+            <a:xfrm>
+              <a:off x="4325824" y="2434706"/>
+              <a:ext cx="2834640" cy="2834640"/>
+            </a:xfrm>
+            <a:prstGeom prst="rect">
+              <a:avLst/>
+            </a:prstGeom>
+          </p:spPr>
+        </p:pic>
+        <p:pic>
+          <p:nvPicPr>
+            <p:cNvPr id="27" name="Picture 26">
+              <a:extLst>
+                <a:ext uri="{FF2B5EF4-FFF2-40B4-BE49-F238E27FC236}">
+                  <a16:creationId xmlns:a16="http://schemas.microsoft.com/office/drawing/2014/main" id="{607EF7E0-F227-3C1A-31E3-F1A33622B09D}"/>
+                </a:ext>
+              </a:extLst>
+            </p:cNvPr>
+            <p:cNvPicPr>
+              <a:picLocks noChangeAspect="1"/>
+            </p:cNvPicPr>
+            <p:nvPr/>
+          </p:nvPicPr>
+          <p:blipFill>
+            <a:blip r:embed="rId4">
               <a:extLst>
                 <a:ext uri="{28A0092B-C50C-407E-A947-70E740481C1C}">
                   <a14:useLocalDpi xmlns:a14="http://schemas.microsoft.com/office/drawing/2010/main" val="0"/>
@@ -3258,7 +3227,7 @@
           </p:blipFill>
           <p:spPr>
             <a:xfrm>
-              <a:off x="8056269" y="4857864"/>
+              <a:off x="1753837" y="2430764"/>
               <a:ext cx="2833500" cy="2833500"/>
             </a:xfrm>
             <a:prstGeom prst="rect">
@@ -3268,10 +3237,10 @@
         </p:pic>
         <p:grpSp>
           <p:nvGrpSpPr>
-            <p:cNvPr id="50" name="Group 49">
+            <p:cNvPr id="51" name="Group 50">
               <a:extLst>
                 <a:ext uri="{FF2B5EF4-FFF2-40B4-BE49-F238E27FC236}">
-                  <a16:creationId xmlns:a16="http://schemas.microsoft.com/office/drawing/2014/main" id="{E073045C-F4DE-EB18-BA93-8A7ED6BBFB40}"/>
+                  <a16:creationId xmlns:a16="http://schemas.microsoft.com/office/drawing/2014/main" id="{85056089-343E-1D31-CACD-1271730819FC}"/>
                 </a:ext>
               </a:extLst>
             </p:cNvPr>
@@ -3281,17 +3250,17 @@
           <p:grpSpPr>
             <a:xfrm>
               <a:off x="512923" y="4836286"/>
-              <a:ext cx="7892404" cy="5425562"/>
+              <a:ext cx="10434231" cy="5425562"/>
               <a:chOff x="512923" y="4836286"/>
-              <a:chExt cx="7892404" cy="5425562"/>
+              <a:chExt cx="10434231" cy="5425562"/>
             </a:xfrm>
           </p:grpSpPr>
           <p:pic>
             <p:nvPicPr>
-              <p:cNvPr id="37" name="Picture 36">
+              <p:cNvPr id="39" name="Picture 38">
                 <a:extLst>
                   <a:ext uri="{FF2B5EF4-FFF2-40B4-BE49-F238E27FC236}">
-                    <a16:creationId xmlns:a16="http://schemas.microsoft.com/office/drawing/2014/main" id="{A5B2D1D4-44B8-3D0A-FD22-0F668F2DC746}"/>
+                    <a16:creationId xmlns:a16="http://schemas.microsoft.com/office/drawing/2014/main" id="{A50F4D04-F764-4FF9-9B25-1F4A575F753F}"/>
                   </a:ext>
                 </a:extLst>
               </p:cNvPr>
@@ -3301,7 +3270,7 @@
               <p:nvPr/>
             </p:nvPicPr>
             <p:blipFill>
-              <a:blip r:embed="rId6">
+              <a:blip r:embed="rId5">
                 <a:extLst>
                   <a:ext uri="{28A0092B-C50C-407E-A947-70E740481C1C}">
                     <a14:useLocalDpi xmlns:a14="http://schemas.microsoft.com/office/drawing/2010/main" val="0"/>
@@ -3313,7 +3282,7 @@
             </p:blipFill>
             <p:spPr>
               <a:xfrm>
-                <a:off x="5566577" y="4847075"/>
+                <a:off x="8056269" y="4857864"/>
                 <a:ext cx="2833500" cy="2833500"/>
               </a:xfrm>
               <a:prstGeom prst="rect">
@@ -3323,10 +3292,10 @@
           </p:pic>
           <p:grpSp>
             <p:nvGrpSpPr>
-              <p:cNvPr id="49" name="Group 48">
+              <p:cNvPr id="50" name="Group 49">
                 <a:extLst>
                   <a:ext uri="{FF2B5EF4-FFF2-40B4-BE49-F238E27FC236}">
-                    <a16:creationId xmlns:a16="http://schemas.microsoft.com/office/drawing/2014/main" id="{65899FD0-9C04-4562-556B-C60A8AFCD0C3}"/>
+                    <a16:creationId xmlns:a16="http://schemas.microsoft.com/office/drawing/2014/main" id="{E073045C-F4DE-EB18-BA93-8A7ED6BBFB40}"/>
                   </a:ext>
                 </a:extLst>
               </p:cNvPr>
@@ -3336,17 +3305,17 @@
             <p:grpSpPr>
               <a:xfrm>
                 <a:off x="512923" y="4836286"/>
-                <a:ext cx="5360327" cy="5425562"/>
+                <a:ext cx="7892404" cy="5425562"/>
                 <a:chOff x="512923" y="4836286"/>
-                <a:chExt cx="5360327" cy="5425562"/>
+                <a:chExt cx="7892404" cy="5425562"/>
               </a:xfrm>
             </p:grpSpPr>
             <p:pic>
               <p:nvPicPr>
-                <p:cNvPr id="35" name="Picture 34">
+                <p:cNvPr id="37" name="Picture 36">
                   <a:extLst>
                     <a:ext uri="{FF2B5EF4-FFF2-40B4-BE49-F238E27FC236}">
-                      <a16:creationId xmlns:a16="http://schemas.microsoft.com/office/drawing/2014/main" id="{A04D616D-FA50-0451-89A8-F7D5254A7484}"/>
+                      <a16:creationId xmlns:a16="http://schemas.microsoft.com/office/drawing/2014/main" id="{A5B2D1D4-44B8-3D0A-FD22-0F668F2DC746}"/>
                     </a:ext>
                   </a:extLst>
                 </p:cNvPr>
@@ -3356,7 +3325,7 @@
                 <p:nvPr/>
               </p:nvPicPr>
               <p:blipFill>
-                <a:blip r:embed="rId7">
+                <a:blip r:embed="rId6">
                   <a:extLst>
                     <a:ext uri="{28A0092B-C50C-407E-A947-70E740481C1C}">
                       <a14:useLocalDpi xmlns:a14="http://schemas.microsoft.com/office/drawing/2010/main" val="0"/>
@@ -3368,7 +3337,7 @@
               </p:blipFill>
               <p:spPr>
                 <a:xfrm>
-                  <a:off x="3039750" y="4836286"/>
+                  <a:off x="5566577" y="4847075"/>
                   <a:ext cx="2833500" cy="2833500"/>
                 </a:xfrm>
                 <a:prstGeom prst="rect">
@@ -3378,10 +3347,10 @@
             </p:pic>
             <p:grpSp>
               <p:nvGrpSpPr>
-                <p:cNvPr id="48" name="Group 47">
+                <p:cNvPr id="49" name="Group 48">
                   <a:extLst>
                     <a:ext uri="{FF2B5EF4-FFF2-40B4-BE49-F238E27FC236}">
-                      <a16:creationId xmlns:a16="http://schemas.microsoft.com/office/drawing/2014/main" id="{19D80BC9-F62F-A6B9-A207-5493851285AC}"/>
+                      <a16:creationId xmlns:a16="http://schemas.microsoft.com/office/drawing/2014/main" id="{65899FD0-9C04-4562-556B-C60A8AFCD0C3}"/>
                     </a:ext>
                   </a:extLst>
                 </p:cNvPr>
@@ -3390,18 +3359,18 @@
               </p:nvGrpSpPr>
               <p:grpSpPr>
                 <a:xfrm>
-                  <a:off x="512923" y="4847075"/>
-                  <a:ext cx="2838000" cy="5378162"/>
-                  <a:chOff x="512923" y="4847075"/>
-                  <a:chExt cx="2838000" cy="5378162"/>
+                  <a:off x="512923" y="4836286"/>
+                  <a:ext cx="5360327" cy="5425562"/>
+                  <a:chOff x="512923" y="4836286"/>
+                  <a:chExt cx="5360327" cy="5425562"/>
                 </a:xfrm>
               </p:grpSpPr>
               <p:pic>
                 <p:nvPicPr>
-                  <p:cNvPr id="33" name="Picture 32">
+                  <p:cNvPr id="35" name="Picture 34">
                     <a:extLst>
                       <a:ext uri="{FF2B5EF4-FFF2-40B4-BE49-F238E27FC236}">
-                        <a16:creationId xmlns:a16="http://schemas.microsoft.com/office/drawing/2014/main" id="{B7ACD403-2D42-59AB-A9ED-D8D31281FC10}"/>
+                        <a16:creationId xmlns:a16="http://schemas.microsoft.com/office/drawing/2014/main" id="{A04D616D-FA50-0451-89A8-F7D5254A7484}"/>
                       </a:ext>
                     </a:extLst>
                   </p:cNvPr>
@@ -3411,7 +3380,7 @@
                   <p:nvPr/>
                 </p:nvPicPr>
                 <p:blipFill>
-                  <a:blip r:embed="rId8">
+                  <a:blip r:embed="rId7">
                     <a:extLst>
                       <a:ext uri="{28A0092B-C50C-407E-A947-70E740481C1C}">
                         <a14:useLocalDpi xmlns:a14="http://schemas.microsoft.com/office/drawing/2010/main" val="0"/>
@@ -3423,7 +3392,7 @@
                 </p:blipFill>
                 <p:spPr>
                   <a:xfrm>
-                    <a:off x="517423" y="4847075"/>
+                    <a:off x="3039750" y="4836286"/>
                     <a:ext cx="2833500" cy="2833500"/>
                   </a:xfrm>
                   <a:prstGeom prst="rect">
@@ -3446,7 +3415,7 @@
                   <p:nvPr/>
                 </p:nvPicPr>
                 <p:blipFill>
-                  <a:blip r:embed="rId9">
+                  <a:blip r:embed="rId8">
                     <a:extLst>
                       <a:ext uri="{28A0092B-C50C-407E-A947-70E740481C1C}">
                         <a14:useLocalDpi xmlns:a14="http://schemas.microsoft.com/office/drawing/2010/main" val="0"/>
@@ -3466,13 +3435,48 @@
                   </a:prstGeom>
                 </p:spPr>
               </p:pic>
+              <p:pic>
+                <p:nvPicPr>
+                  <p:cNvPr id="43" name="Picture 42">
+                    <a:extLst>
+                      <a:ext uri="{FF2B5EF4-FFF2-40B4-BE49-F238E27FC236}">
+                        <a16:creationId xmlns:a16="http://schemas.microsoft.com/office/drawing/2014/main" id="{1F07A5C8-BDA1-7199-5F3E-D3B08647002C}"/>
+                      </a:ext>
+                    </a:extLst>
+                  </p:cNvPr>
+                  <p:cNvPicPr>
+                    <a:picLocks noChangeAspect="1"/>
+                  </p:cNvPicPr>
+                  <p:nvPr/>
+                </p:nvPicPr>
+                <p:blipFill>
+                  <a:blip r:embed="rId9">
+                    <a:extLst>
+                      <a:ext uri="{28A0092B-C50C-407E-A947-70E740481C1C}">
+                        <a14:useLocalDpi xmlns:a14="http://schemas.microsoft.com/office/drawing/2010/main" val="0"/>
+                      </a:ext>
+                    </a:extLst>
+                  </a:blip>
+                  <a:srcRect/>
+                  <a:stretch/>
+                </p:blipFill>
+                <p:spPr>
+                  <a:xfrm>
+                    <a:off x="3024750" y="7428348"/>
+                    <a:ext cx="2833500" cy="2833500"/>
+                  </a:xfrm>
+                  <a:prstGeom prst="rect">
+                    <a:avLst/>
+                  </a:prstGeom>
+                </p:spPr>
+              </p:pic>
             </p:grpSp>
             <p:pic>
               <p:nvPicPr>
-                <p:cNvPr id="43" name="Picture 42">
+                <p:cNvPr id="45" name="Picture 44">
                   <a:extLst>
                     <a:ext uri="{FF2B5EF4-FFF2-40B4-BE49-F238E27FC236}">
-                      <a16:creationId xmlns:a16="http://schemas.microsoft.com/office/drawing/2014/main" id="{1F07A5C8-BDA1-7199-5F3E-D3B08647002C}"/>
+                      <a16:creationId xmlns:a16="http://schemas.microsoft.com/office/drawing/2014/main" id="{35DB56F3-7C38-E29D-F1FE-492DAD68A498}"/>
                     </a:ext>
                   </a:extLst>
                 </p:cNvPr>
@@ -3494,7 +3498,7 @@
               </p:blipFill>
               <p:spPr>
                 <a:xfrm>
-                  <a:off x="3024750" y="7428348"/>
+                  <a:off x="5571827" y="7417559"/>
                   <a:ext cx="2833500" cy="2833500"/>
                 </a:xfrm>
                 <a:prstGeom prst="rect">
@@ -3505,10 +3509,10 @@
           </p:grpSp>
           <p:pic>
             <p:nvPicPr>
-              <p:cNvPr id="45" name="Picture 44">
+              <p:cNvPr id="47" name="Picture 46">
                 <a:extLst>
                   <a:ext uri="{FF2B5EF4-FFF2-40B4-BE49-F238E27FC236}">
-                    <a16:creationId xmlns:a16="http://schemas.microsoft.com/office/drawing/2014/main" id="{35DB56F3-7C38-E29D-F1FE-492DAD68A498}"/>
+                    <a16:creationId xmlns:a16="http://schemas.microsoft.com/office/drawing/2014/main" id="{5F89D521-B3F6-E471-AF7D-DAF0E8960D73}"/>
                   </a:ext>
                 </a:extLst>
               </p:cNvPr>
@@ -3530,7 +3534,7 @@
             </p:blipFill>
             <p:spPr>
               <a:xfrm>
-                <a:off x="5571827" y="7417559"/>
+                <a:off x="8113654" y="7413486"/>
                 <a:ext cx="2833500" cy="2833500"/>
               </a:xfrm>
               <a:prstGeom prst="rect">
@@ -3541,10 +3545,10 @@
         </p:grpSp>
         <p:pic>
           <p:nvPicPr>
-            <p:cNvPr id="47" name="Picture 46">
+            <p:cNvPr id="7" name="Picture 6" descr="A graph of a graph&#10;&#10;AI-generated content may be incorrect.">
               <a:extLst>
                 <a:ext uri="{FF2B5EF4-FFF2-40B4-BE49-F238E27FC236}">
-                  <a16:creationId xmlns:a16="http://schemas.microsoft.com/office/drawing/2014/main" id="{5F89D521-B3F6-E471-AF7D-DAF0E8960D73}"/>
+                  <a16:creationId xmlns:a16="http://schemas.microsoft.com/office/drawing/2014/main" id="{72CB6893-C1E6-7C1E-BB7D-E14E3C28AD3D}"/>
                 </a:ext>
               </a:extLst>
             </p:cNvPr>
@@ -3555,19 +3559,21 @@
           </p:nvPicPr>
           <p:blipFill>
             <a:blip r:embed="rId12">
+              <a:alphaModFix/>
               <a:extLst>
                 <a:ext uri="{28A0092B-C50C-407E-A947-70E740481C1C}">
                   <a14:useLocalDpi xmlns:a14="http://schemas.microsoft.com/office/drawing/2010/main" val="0"/>
                 </a:ext>
               </a:extLst>
             </a:blip>
-            <a:srcRect/>
-            <a:stretch/>
+            <a:stretch>
+              <a:fillRect/>
+            </a:stretch>
           </p:blipFill>
           <p:spPr>
             <a:xfrm>
-              <a:off x="8113654" y="7413486"/>
-              <a:ext cx="2833500" cy="2833500"/>
+              <a:off x="516283" y="4846505"/>
+              <a:ext cx="2834640" cy="2834640"/>
             </a:xfrm>
             <a:prstGeom prst="rect">
               <a:avLst/>

</xml_diff>